<commit_message>
Update flowchart deck: fix stale numbers (8->10 papers, final Bug1 count), reflect completed movie/SC extension, add 2 slides for the new baseline/ control battery and the retrieval-ladder + verification-precision audit.
Structural validation passed; LibreOffice unavailable in this environment
so visual rendering was not checked -- text-only edits, low risk, but
noting the gap rather than claiming a check that wasn't done.
</commit_message>
<xml_diff>
--- a/docs/NeuroLens-RAG-flowchart.pptx
+++ b/docs/NeuroLens-RAG-flowchart.pptx
@@ -10,11 +10,13 @@
     <p:sldId id="258" r:id="rId9"/>
     <p:sldId id="259" r:id="rId10"/>
     <p:sldId id="260" r:id="rId11"/>
+    <p:sldId id="268" r:id="rId19"/>
     <p:sldId id="261" r:id="rId12"/>
     <p:sldId id="262" r:id="rId13"/>
     <p:sldId id="263" r:id="rId14"/>
     <p:sldId id="264" r:id="rId15"/>
     <p:sldId id="265" r:id="rId16"/>
+    <p:sldId id="269" r:id="rId20"/>
     <p:sldId id="266" r:id="rId17"/>
     <p:sldId id="267" r:id="rId18"/>
   </p:sldIdLst>
@@ -3601,7 +3603,7 @@
                 </a:solidFill>
                 <a:latin typeface="Calibri"/>
               </a:rPr>
-              <a:t>43 AGREE · 4 UNCLEAR · 1 DISAGREE</a:t>
+              <a:t>23 AGREE · 47 UNCLEAR (of 70, final)</a:t>
             </a:r>
           </a:p>
           <a:p>
@@ -4946,7 +4948,7 @@
                 </a:solidFill>
                 <a:latin typeface="Calibri"/>
               </a:rPr>
-              <a:t>8 papers. Every retrieval and grounding result is bounded by this.</a:t>
+              <a:t>10 papers. Every retrieval and grounding result is bounded by this.</a:t>
             </a:r>
           </a:p>
         </p:txBody>
@@ -5177,7 +5179,7 @@
                 </a:solidFill>
                 <a:latin typeface="Calibri"/>
               </a:rPr>
-              <a:t>Next: a messier HCP dataset</a:t>
+              <a:t>Extension already underway</a:t>
             </a:r>
           </a:p>
         </p:txBody>
@@ -5216,7 +5218,1884 @@
                 </a:solidFill>
                 <a:latin typeface="Calibri"/>
               </a:rPr>
-              <a:t>data/raw/hcp_movie_watching/ reserved — continuous, naturalistic, to test whether convergence survives.</a:t>
+              <a:t>174-subject movie + structural-connectivity pipeline complete, 0 failures — now its own repo, naturalistic-brain-dynamics.</a:t>
+            </a:r>
+          </a:p>
+        </p:txBody>
+      </p:sp>
+    </p:spTree>
+  </p:cSld>
+  <p:clrMapOvr>
+    <a:masterClrMapping/>
+  </p:clrMapOvr>
+</p:sld>
+</file>
+
+<file path=ppt/slides/slide13.xml><?xml version="1.0" encoding="utf-8"?>
+<p:sld xmlns:a="http://schemas.openxmlformats.org/drawingml/2006/main" xmlns:p="http://schemas.openxmlformats.org/presentationml/2006/main" xmlns:r="http://schemas.openxmlformats.org/officeDocument/2006/relationships">
+  <p:cSld>
+    <p:bg>
+      <p:bgPr>
+        <a:solidFill>
+          <a:srgbClr val="FFFFFF"/>
+        </a:solidFill>
+        <a:effectLst/>
+      </p:bgPr>
+    </p:bg>
+    <p:spTree>
+      <p:nvGrpSpPr>
+        <p:cNvPr id="1" name=""/>
+        <p:cNvGrpSpPr/>
+        <p:nvPr/>
+      </p:nvGrpSpPr>
+      <p:grpSpPr/>
+      <p:sp>
+        <p:nvSpPr>
+          <p:cNvPr id="2" name="TextBox 1"/>
+          <p:cNvSpPr txBox="1"/>
+          <p:nvPr/>
+        </p:nvSpPr>
+        <p:spPr>
+          <a:xfrm>
+            <a:off x="548640" y="292608"/>
+            <a:ext cx="7315200" cy="256032"/>
+          </a:xfrm>
+          <a:prstGeom prst="rect">
+            <a:avLst/>
+          </a:prstGeom>
+          <a:noFill/>
+        </p:spPr>
+        <p:txBody>
+          <a:bodyPr wrap="square" anchor="t" lIns="0" rIns="0" tIns="0" bIns="0">
+            <a:spAutoFit/>
+          </a:bodyPr>
+          <a:lstStyle/>
+          <a:p>
+            <a:pPr algn="l">
+              <a:lnSpc>
+                <a:spcPct val="100000"/>
+              </a:lnSpc>
+            </a:pPr>
+            <a:r>
+              <a:rPr sz="1100" b="1" i="0">
+                <a:solidFill>
+                  <a:srgbClr val="3D5A80"/>
+                </a:solidFill>
+                <a:latin typeface="Calibri"/>
+              </a:rPr>
+              <a:t>BASELINE &amp; CONTROL CHECKS</a:t>
+            </a:r>
+          </a:p>
+        </p:txBody>
+      </p:sp>
+      <p:sp>
+        <p:nvSpPr>
+          <p:cNvPr id="3" name="TextBox 2"/>
+          <p:cNvSpPr txBox="1"/>
+          <p:nvPr/>
+        </p:nvSpPr>
+        <p:spPr>
+          <a:xfrm>
+            <a:off x="548640" y="603504"/>
+            <a:ext cx="11064240" cy="640080"/>
+          </a:xfrm>
+          <a:prstGeom prst="rect">
+            <a:avLst/>
+          </a:prstGeom>
+          <a:noFill/>
+        </p:spPr>
+        <p:txBody>
+          <a:bodyPr wrap="square" anchor="t" lIns="0" rIns="0" tIns="0" bIns="0">
+            <a:spAutoFit/>
+          </a:bodyPr>
+          <a:lstStyle/>
+          <a:p>
+            <a:pPr algn="l">
+              <a:lnSpc>
+                <a:spcPct val="100000"/>
+              </a:lnSpc>
+            </a:pPr>
+            <a:r>
+              <a:rPr sz="2800" b="1" i="0">
+                <a:solidFill>
+                  <a:srgbClr val="1B2A44"/>
+                </a:solidFill>
+                <a:latin typeface="Cambria"/>
+              </a:rPr>
+              <a:t>Does the model need what we think it needs?</a:t>
+            </a:r>
+          </a:p>
+        </p:txBody>
+      </p:sp>
+      <p:sp>
+        <p:nvSpPr>
+          <p:cNvPr id="4" name="TextBox 3"/>
+          <p:cNvSpPr txBox="1"/>
+          <p:nvPr/>
+        </p:nvSpPr>
+        <p:spPr>
+          <a:xfrm>
+            <a:off x="640080" y="1920240"/>
+            <a:ext cx="3291840" cy="365760"/>
+          </a:xfrm>
+          <a:prstGeom prst="rect">
+            <a:avLst/>
+          </a:prstGeom>
+          <a:noFill/>
+        </p:spPr>
+        <p:txBody>
+          <a:bodyPr wrap="square" anchor="t" lIns="0" rIns="0" tIns="0" bIns="0">
+            <a:spAutoFit/>
+          </a:bodyPr>
+          <a:lstStyle/>
+          <a:p>
+            <a:pPr algn="l">
+              <a:lnSpc>
+                <a:spcPct val="100000"/>
+              </a:lnSpc>
+            </a:pPr>
+            <a:r>
+              <a:rPr sz="1200" b="1" i="0">
+                <a:solidFill>
+                  <a:srgbClr val="FFFFFF"/>
+                </a:solidFill>
+                <a:latin typeface="Calibri"/>
+              </a:rPr>
+              <a:t/>
+            </a:r>
+          </a:p>
+        </p:txBody>
+      </p:sp>
+      <p:sp>
+        <p:nvSpPr>
+          <p:cNvPr id="5" name="TextBox 4"/>
+          <p:cNvSpPr txBox="1"/>
+          <p:nvPr/>
+        </p:nvSpPr>
+        <p:spPr>
+          <a:xfrm>
+            <a:off x="3931920" y="1920240"/>
+            <a:ext cx="2743200" cy="365760"/>
+          </a:xfrm>
+          <a:prstGeom prst="rect">
+            <a:avLst/>
+          </a:prstGeom>
+          <a:noFill/>
+        </p:spPr>
+        <p:txBody>
+          <a:bodyPr wrap="square" anchor="t" lIns="0" rIns="0" tIns="0" bIns="0">
+            <a:spAutoFit/>
+          </a:bodyPr>
+          <a:lstStyle/>
+          <a:p>
+            <a:pPr algn="l">
+              <a:lnSpc>
+                <a:spcPct val="100000"/>
+              </a:lnSpc>
+            </a:pPr>
+            <a:r>
+              <a:rPr sz="1200" b="1" i="0">
+                <a:solidFill>
+                  <a:srgbClr val="1B2A44"/>
+                </a:solidFill>
+                <a:latin typeface="Calibri"/>
+              </a:rPr>
+              <a:t>Mean F1 (95% CI)</a:t>
+            </a:r>
+          </a:p>
+        </p:txBody>
+      </p:sp>
+      <p:sp>
+        <p:nvSpPr>
+          <p:cNvPr id="6" name="TextBox 5"/>
+          <p:cNvSpPr txBox="1"/>
+          <p:nvPr/>
+        </p:nvSpPr>
+        <p:spPr>
+          <a:xfrm>
+            <a:off x="6675120" y="1920240"/>
+            <a:ext cx="2743200" cy="365760"/>
+          </a:xfrm>
+          <a:prstGeom prst="rect">
+            <a:avLst/>
+          </a:prstGeom>
+          <a:noFill/>
+        </p:spPr>
+        <p:txBody>
+          <a:bodyPr wrap="square" anchor="t" lIns="0" rIns="0" tIns="0" bIns="0">
+            <a:spAutoFit/>
+          </a:bodyPr>
+          <a:lstStyle/>
+          <a:p>
+            <a:pPr algn="l">
+              <a:lnSpc>
+                <a:spcPct val="100000"/>
+              </a:lnSpc>
+            </a:pPr>
+            <a:r>
+              <a:rPr sz="1200" b="1" i="0">
+                <a:solidFill>
+                  <a:srgbClr val="1B2A44"/>
+                </a:solidFill>
+                <a:latin typeface="Calibri"/>
+              </a:rPr>
+              <a:t>What it tests</a:t>
+            </a:r>
+          </a:p>
+        </p:txBody>
+      </p:sp>
+      <p:sp>
+        <p:nvSpPr>
+          <p:cNvPr id="7" name="TextBox 6"/>
+          <p:cNvSpPr txBox="1"/>
+          <p:nvPr/>
+        </p:nvSpPr>
+        <p:spPr>
+          <a:xfrm>
+            <a:off x="9418320" y="1920240"/>
+            <a:ext cx="1828800" cy="365760"/>
+          </a:xfrm>
+          <a:prstGeom prst="rect">
+            <a:avLst/>
+          </a:prstGeom>
+          <a:noFill/>
+        </p:spPr>
+        <p:txBody>
+          <a:bodyPr wrap="square" anchor="t" lIns="0" rIns="0" tIns="0" bIns="0">
+            <a:spAutoFit/>
+          </a:bodyPr>
+          <a:lstStyle/>
+          <a:p>
+            <a:pPr algn="l">
+              <a:lnSpc>
+                <a:spcPct val="100000"/>
+              </a:lnSpc>
+            </a:pPr>
+            <a:r>
+              <a:rPr sz="1200" b="1" i="0">
+                <a:solidFill>
+                  <a:srgbClr val="1B2A44"/>
+                </a:solidFill>
+                <a:latin typeface="Calibri"/>
+              </a:rPr>
+              <a:t>Winner</a:t>
+            </a:r>
+          </a:p>
+        </p:txBody>
+      </p:sp>
+      <p:sp>
+        <p:nvSpPr>
+          <p:cNvPr id="8" name="Rectangle 7"/>
+          <p:cNvSpPr/>
+          <p:nvPr/>
+        </p:nvSpPr>
+        <p:spPr>
+          <a:xfrm>
+            <a:off x="640080" y="2377440"/>
+            <a:ext cx="10607040" cy="594360"/>
+          </a:xfrm>
+          <a:prstGeom prst="rect">
+            <a:avLst/>
+          </a:prstGeom>
+          <a:solidFill>
+            <a:srgbClr val="F7F9FB"/>
+          </a:solidFill>
+          <a:ln>
+            <a:noFill/>
+          </a:ln>
+          <a:effectLst/>
+        </p:spPr>
+        <p:style>
+          <a:lnRef idx="1">
+            <a:schemeClr val="accent1"/>
+          </a:lnRef>
+          <a:fillRef idx="3">
+            <a:schemeClr val="accent1"/>
+          </a:fillRef>
+          <a:effectRef idx="2">
+            <a:schemeClr val="accent1"/>
+          </a:effectRef>
+          <a:fontRef idx="minor">
+            <a:schemeClr val="lt1"/>
+          </a:fontRef>
+        </p:style>
+        <p:txBody>
+          <a:bodyPr rtlCol="0" anchor="ctr" wrap="square" lIns="73152" rIns="73152" tIns="36576" bIns="36576"/>
+          <a:lstStyle/>
+          <a:p>
+            <a:pPr algn="ctr">
+              <a:lnSpc>
+                <a:spcPct val="100000"/>
+              </a:lnSpc>
+            </a:pPr>
+            <a:r>
+              <a:rPr sz="1200" b="0">
+                <a:solidFill>
+                  <a:srgbClr val="1B2A44"/>
+                </a:solidFill>
+                <a:latin typeface="Calibri"/>
+              </a:rPr>
+              <a:t/>
+            </a:r>
+          </a:p>
+        </p:txBody>
+      </p:sp>
+      <p:sp>
+        <p:nvSpPr>
+          <p:cNvPr id="9" name="TextBox 8"/>
+          <p:cNvSpPr txBox="1"/>
+          <p:nvPr/>
+        </p:nvSpPr>
+        <p:spPr>
+          <a:xfrm>
+            <a:off x="777240" y="2496312"/>
+            <a:ext cx="3108960" cy="457200"/>
+          </a:xfrm>
+          <a:prstGeom prst="rect">
+            <a:avLst/>
+          </a:prstGeom>
+          <a:noFill/>
+        </p:spPr>
+        <p:txBody>
+          <a:bodyPr wrap="square" anchor="t" lIns="0" rIns="0" tIns="0" bIns="0">
+            <a:spAutoFit/>
+          </a:bodyPr>
+          <a:lstStyle/>
+          <a:p>
+            <a:pPr algn="l">
+              <a:lnSpc>
+                <a:spcPct val="100000"/>
+              </a:lnSpc>
+            </a:pPr>
+            <a:r>
+              <a:rPr sz="1300" b="1" i="0">
+                <a:solidFill>
+                  <a:srgbClr val="1B2A44"/>
+                </a:solidFill>
+                <a:latin typeface="Calibri"/>
+              </a:rPr>
+              <a:t>FlattenMLP (flat 9,600-d, no time structure)</a:t>
+            </a:r>
+          </a:p>
+        </p:txBody>
+      </p:sp>
+      <p:sp>
+        <p:nvSpPr>
+          <p:cNvPr id="10" name="TextBox 9"/>
+          <p:cNvSpPr txBox="1"/>
+          <p:nvPr/>
+        </p:nvSpPr>
+        <p:spPr>
+          <a:xfrm>
+            <a:off x="4069080" y="2496312"/>
+            <a:ext cx="2560320" cy="457200"/>
+          </a:xfrm>
+          <a:prstGeom prst="rect">
+            <a:avLst/>
+          </a:prstGeom>
+          <a:noFill/>
+        </p:spPr>
+        <p:txBody>
+          <a:bodyPr wrap="square" anchor="t" lIns="0" rIns="0" tIns="0" bIns="0">
+            <a:spAutoFit/>
+          </a:bodyPr>
+          <a:lstStyle/>
+          <a:p>
+            <a:pPr algn="l">
+              <a:lnSpc>
+                <a:spcPct val="100000"/>
+              </a:lnSpc>
+            </a:pPr>
+            <a:r>
+              <a:rPr sz="1250" b="0" i="0">
+                <a:solidFill>
+                  <a:srgbClr val="51607A"/>
+                </a:solidFill>
+                <a:latin typeface="Calibri"/>
+              </a:rPr>
+              <a:t>0.907  [0.882, 0.933]</a:t>
+            </a:r>
+          </a:p>
+        </p:txBody>
+      </p:sp>
+      <p:sp>
+        <p:nvSpPr>
+          <p:cNvPr id="11" name="TextBox 10"/>
+          <p:cNvSpPr txBox="1"/>
+          <p:nvPr/>
+        </p:nvSpPr>
+        <p:spPr>
+          <a:xfrm>
+            <a:off x="6812280" y="2496312"/>
+            <a:ext cx="2560320" cy="457200"/>
+          </a:xfrm>
+          <a:prstGeom prst="rect">
+            <a:avLst/>
+          </a:prstGeom>
+          <a:noFill/>
+        </p:spPr>
+        <p:txBody>
+          <a:bodyPr wrap="square" anchor="t" lIns="0" rIns="0" tIns="0" bIns="0">
+            <a:spAutoFit/>
+          </a:bodyPr>
+          <a:lstStyle/>
+          <a:p>
+            <a:pPr algn="l">
+              <a:lnSpc>
+                <a:spcPct val="100000"/>
+              </a:lnSpc>
+            </a:pPr>
+            <a:r>
+              <a:rPr sz="1250" b="0" i="0">
+                <a:solidFill>
+                  <a:srgbClr val="51607A"/>
+                </a:solidFill>
+                <a:latin typeface="Calibri"/>
+              </a:rPr>
+              <a:t>Ties GRU (p=0.73)</a:t>
+            </a:r>
+          </a:p>
+        </p:txBody>
+      </p:sp>
+      <p:sp>
+        <p:nvSpPr>
+          <p:cNvPr id="12" name="TextBox 11"/>
+          <p:cNvSpPr txBox="1"/>
+          <p:nvPr/>
+        </p:nvSpPr>
+        <p:spPr>
+          <a:xfrm>
+            <a:off x="9555480" y="2450592"/>
+            <a:ext cx="1645920" cy="274320"/>
+          </a:xfrm>
+          <a:prstGeom prst="rect">
+            <a:avLst/>
+          </a:prstGeom>
+          <a:noFill/>
+        </p:spPr>
+        <p:txBody>
+          <a:bodyPr wrap="square" anchor="t" lIns="0" rIns="0" tIns="0" bIns="0">
+            <a:spAutoFit/>
+          </a:bodyPr>
+          <a:lstStyle/>
+          <a:p>
+            <a:pPr algn="l">
+              <a:lnSpc>
+                <a:spcPct val="100000"/>
+              </a:lnSpc>
+            </a:pPr>
+            <a:r>
+              <a:rPr sz="1300" b="1" i="0">
+                <a:solidFill>
+                  <a:srgbClr val="3D5A80"/>
+                </a:solidFill>
+                <a:latin typeface="Calibri"/>
+              </a:rPr>
+              <a:t>Transformer</a:t>
+            </a:r>
+          </a:p>
+        </p:txBody>
+      </p:sp>
+      <p:sp>
+        <p:nvSpPr>
+          <p:cNvPr id="13" name="TextBox 12"/>
+          <p:cNvSpPr txBox="1"/>
+          <p:nvPr/>
+        </p:nvSpPr>
+        <p:spPr>
+          <a:xfrm>
+            <a:off x="9555480" y="2724912"/>
+            <a:ext cx="1645920" cy="274320"/>
+          </a:xfrm>
+          <a:prstGeom prst="rect">
+            <a:avLst/>
+          </a:prstGeom>
+          <a:noFill/>
+        </p:spPr>
+        <p:txBody>
+          <a:bodyPr wrap="square" anchor="t" lIns="0" rIns="0" tIns="0" bIns="0">
+            <a:spAutoFit/>
+          </a:bodyPr>
+          <a:lstStyle/>
+          <a:p>
+            <a:pPr algn="l">
+              <a:lnSpc>
+                <a:spcPct val="100000"/>
+              </a:lnSpc>
+            </a:pPr>
+            <a:r>
+              <a:rPr sz="1050" b="0" i="1">
+                <a:solidFill>
+                  <a:srgbClr val="51607A"/>
+                </a:solidFill>
+                <a:latin typeface="Calibri"/>
+              </a:rPr>
+              <a:t>p &lt; 0.0001 (Transformer wins)</a:t>
+            </a:r>
+          </a:p>
+        </p:txBody>
+      </p:sp>
+      <p:sp>
+        <p:nvSpPr>
+          <p:cNvPr id="14" name="Rectangle 13"/>
+          <p:cNvSpPr/>
+          <p:nvPr/>
+        </p:nvSpPr>
+        <p:spPr>
+          <a:xfrm>
+            <a:off x="640080" y="3063240"/>
+            <a:ext cx="10607040" cy="594360"/>
+          </a:xfrm>
+          <a:prstGeom prst="rect">
+            <a:avLst/>
+          </a:prstGeom>
+          <a:solidFill>
+            <a:srgbClr val="FFFFFF"/>
+          </a:solidFill>
+          <a:ln>
+            <a:noFill/>
+          </a:ln>
+          <a:effectLst/>
+        </p:spPr>
+        <p:style>
+          <a:lnRef idx="1">
+            <a:schemeClr val="accent1"/>
+          </a:lnRef>
+          <a:fillRef idx="3">
+            <a:schemeClr val="accent1"/>
+          </a:fillRef>
+          <a:effectRef idx="2">
+            <a:schemeClr val="accent1"/>
+          </a:effectRef>
+          <a:fontRef idx="minor">
+            <a:schemeClr val="lt1"/>
+          </a:fontRef>
+        </p:style>
+        <p:txBody>
+          <a:bodyPr rtlCol="0" anchor="ctr" wrap="square" lIns="73152" rIns="73152" tIns="36576" bIns="36576"/>
+          <a:lstStyle/>
+          <a:p>
+            <a:pPr algn="ctr">
+              <a:lnSpc>
+                <a:spcPct val="100000"/>
+              </a:lnSpc>
+            </a:pPr>
+            <a:r>
+              <a:rPr sz="1200" b="0">
+                <a:solidFill>
+                  <a:srgbClr val="1B2A44"/>
+                </a:solidFill>
+                <a:latin typeface="Calibri"/>
+              </a:rPr>
+              <a:t/>
+            </a:r>
+          </a:p>
+        </p:txBody>
+      </p:sp>
+      <p:sp>
+        <p:nvSpPr>
+          <p:cNvPr id="15" name="TextBox 14"/>
+          <p:cNvSpPr txBox="1"/>
+          <p:nvPr/>
+        </p:nvSpPr>
+        <p:spPr>
+          <a:xfrm>
+            <a:off x="777240" y="3182112"/>
+            <a:ext cx="3108960" cy="457200"/>
+          </a:xfrm>
+          <a:prstGeom prst="rect">
+            <a:avLst/>
+          </a:prstGeom>
+          <a:noFill/>
+        </p:spPr>
+        <p:txBody>
+          <a:bodyPr wrap="square" anchor="t" lIns="0" rIns="0" tIns="0" bIns="0">
+            <a:spAutoFit/>
+          </a:bodyPr>
+          <a:lstStyle/>
+          <a:p>
+            <a:pPr algn="l">
+              <a:lnSpc>
+                <a:spcPct val="100000"/>
+              </a:lnSpc>
+            </a:pPr>
+            <a:r>
+              <a:rPr sz="1300" b="1" i="0">
+                <a:solidFill>
+                  <a:srgbClr val="1B2A44"/>
+                </a:solidFill>
+                <a:latin typeface="Calibri"/>
+              </a:rPr>
+              <a:t>MeanPoolMLP (temporal info destroyed)</a:t>
+            </a:r>
+          </a:p>
+        </p:txBody>
+      </p:sp>
+      <p:sp>
+        <p:nvSpPr>
+          <p:cNvPr id="16" name="TextBox 15"/>
+          <p:cNvSpPr txBox="1"/>
+          <p:nvPr/>
+        </p:nvSpPr>
+        <p:spPr>
+          <a:xfrm>
+            <a:off x="4069080" y="3182112"/>
+            <a:ext cx="2560320" cy="457200"/>
+          </a:xfrm>
+          <a:prstGeom prst="rect">
+            <a:avLst/>
+          </a:prstGeom>
+          <a:noFill/>
+        </p:spPr>
+        <p:txBody>
+          <a:bodyPr wrap="square" anchor="t" lIns="0" rIns="0" tIns="0" bIns="0">
+            <a:spAutoFit/>
+          </a:bodyPr>
+          <a:lstStyle/>
+          <a:p>
+            <a:pPr algn="l">
+              <a:lnSpc>
+                <a:spcPct val="100000"/>
+              </a:lnSpc>
+            </a:pPr>
+            <a:r>
+              <a:rPr sz="1250" b="0" i="0">
+                <a:solidFill>
+                  <a:srgbClr val="51607A"/>
+                </a:solidFill>
+                <a:latin typeface="Calibri"/>
+              </a:rPr>
+              <a:t>0.654  [0.616, 0.694]</a:t>
+            </a:r>
+          </a:p>
+        </p:txBody>
+      </p:sp>
+      <p:sp>
+        <p:nvSpPr>
+          <p:cNvPr id="17" name="TextBox 16"/>
+          <p:cNvSpPr txBox="1"/>
+          <p:nvPr/>
+        </p:nvSpPr>
+        <p:spPr>
+          <a:xfrm>
+            <a:off x="6812280" y="3182112"/>
+            <a:ext cx="2560320" cy="457200"/>
+          </a:xfrm>
+          <a:prstGeom prst="rect">
+            <a:avLst/>
+          </a:prstGeom>
+          <a:noFill/>
+        </p:spPr>
+        <p:txBody>
+          <a:bodyPr wrap="square" anchor="t" lIns="0" rIns="0" tIns="0" bIns="0">
+            <a:spAutoFit/>
+          </a:bodyPr>
+          <a:lstStyle/>
+          <a:p>
+            <a:pPr algn="l">
+              <a:lnSpc>
+                <a:spcPct val="100000"/>
+              </a:lnSpc>
+            </a:pPr>
+            <a:r>
+              <a:rPr sz="1250" b="0" i="0">
+                <a:solidFill>
+                  <a:srgbClr val="51607A"/>
+                </a:solidFill>
+                <a:latin typeface="Calibri"/>
+              </a:rPr>
+              <a:t>Loses to GRU too (p &lt; 0.0001)</a:t>
+            </a:r>
+          </a:p>
+        </p:txBody>
+      </p:sp>
+      <p:sp>
+        <p:nvSpPr>
+          <p:cNvPr id="18" name="TextBox 17"/>
+          <p:cNvSpPr txBox="1"/>
+          <p:nvPr/>
+        </p:nvSpPr>
+        <p:spPr>
+          <a:xfrm>
+            <a:off x="9555480" y="3136392"/>
+            <a:ext cx="1645920" cy="274320"/>
+          </a:xfrm>
+          <a:prstGeom prst="rect">
+            <a:avLst/>
+          </a:prstGeom>
+          <a:noFill/>
+        </p:spPr>
+        <p:txBody>
+          <a:bodyPr wrap="square" anchor="t" lIns="0" rIns="0" tIns="0" bIns="0">
+            <a:spAutoFit/>
+          </a:bodyPr>
+          <a:lstStyle/>
+          <a:p>
+            <a:pPr algn="l">
+              <a:lnSpc>
+                <a:spcPct val="100000"/>
+              </a:lnSpc>
+            </a:pPr>
+            <a:r>
+              <a:rPr sz="1300" b="1" i="0">
+                <a:solidFill>
+                  <a:srgbClr val="3D5A80"/>
+                </a:solidFill>
+                <a:latin typeface="Calibri"/>
+              </a:rPr>
+              <a:t>Transformer</a:t>
+            </a:r>
+          </a:p>
+        </p:txBody>
+      </p:sp>
+      <p:sp>
+        <p:nvSpPr>
+          <p:cNvPr id="19" name="TextBox 18"/>
+          <p:cNvSpPr txBox="1"/>
+          <p:nvPr/>
+        </p:nvSpPr>
+        <p:spPr>
+          <a:xfrm>
+            <a:off x="9555480" y="3410712"/>
+            <a:ext cx="1645920" cy="274320"/>
+          </a:xfrm>
+          <a:prstGeom prst="rect">
+            <a:avLst/>
+          </a:prstGeom>
+          <a:noFill/>
+        </p:spPr>
+        <p:txBody>
+          <a:bodyPr wrap="square" anchor="t" lIns="0" rIns="0" tIns="0" bIns="0">
+            <a:spAutoFit/>
+          </a:bodyPr>
+          <a:lstStyle/>
+          <a:p>
+            <a:pPr algn="l">
+              <a:lnSpc>
+                <a:spcPct val="100000"/>
+              </a:lnSpc>
+            </a:pPr>
+            <a:r>
+              <a:rPr sz="1050" b="0" i="1">
+                <a:solidFill>
+                  <a:srgbClr val="51607A"/>
+                </a:solidFill>
+                <a:latin typeface="Calibri"/>
+              </a:rPr>
+              <a:t>p &lt; 0.0001</a:t>
+            </a:r>
+          </a:p>
+        </p:txBody>
+      </p:sp>
+      <p:sp>
+        <p:nvSpPr>
+          <p:cNvPr id="20" name="Rectangle 19"/>
+          <p:cNvSpPr/>
+          <p:nvPr/>
+        </p:nvSpPr>
+        <p:spPr>
+          <a:xfrm>
+            <a:off x="640080" y="3749039"/>
+            <a:ext cx="10607040" cy="594360"/>
+          </a:xfrm>
+          <a:prstGeom prst="rect">
+            <a:avLst/>
+          </a:prstGeom>
+          <a:solidFill>
+            <a:srgbClr val="F7F9FB"/>
+          </a:solidFill>
+          <a:ln>
+            <a:noFill/>
+          </a:ln>
+          <a:effectLst/>
+        </p:spPr>
+        <p:style>
+          <a:lnRef idx="1">
+            <a:schemeClr val="accent1"/>
+          </a:lnRef>
+          <a:fillRef idx="3">
+            <a:schemeClr val="accent1"/>
+          </a:fillRef>
+          <a:effectRef idx="2">
+            <a:schemeClr val="accent1"/>
+          </a:effectRef>
+          <a:fontRef idx="minor">
+            <a:schemeClr val="lt1"/>
+          </a:fontRef>
+        </p:style>
+        <p:txBody>
+          <a:bodyPr rtlCol="0" anchor="ctr" wrap="square" lIns="73152" rIns="73152" tIns="36576" bIns="36576"/>
+          <a:lstStyle/>
+          <a:p>
+            <a:pPr algn="ctr">
+              <a:lnSpc>
+                <a:spcPct val="100000"/>
+              </a:lnSpc>
+            </a:pPr>
+            <a:r>
+              <a:rPr sz="1200" b="0">
+                <a:solidFill>
+                  <a:srgbClr val="1B2A44"/>
+                </a:solidFill>
+                <a:latin typeface="Calibri"/>
+              </a:rPr>
+              <a:t/>
+            </a:r>
+          </a:p>
+        </p:txBody>
+      </p:sp>
+      <p:sp>
+        <p:nvSpPr>
+          <p:cNvPr id="21" name="TextBox 20"/>
+          <p:cNvSpPr txBox="1"/>
+          <p:nvPr/>
+        </p:nvSpPr>
+        <p:spPr>
+          <a:xfrm>
+            <a:off x="777240" y="3867911"/>
+            <a:ext cx="3108960" cy="457200"/>
+          </a:xfrm>
+          <a:prstGeom prst="rect">
+            <a:avLst/>
+          </a:prstGeom>
+          <a:noFill/>
+        </p:spPr>
+        <p:txBody>
+          <a:bodyPr wrap="square" anchor="t" lIns="0" rIns="0" tIns="0" bIns="0">
+            <a:spAutoFit/>
+          </a:bodyPr>
+          <a:lstStyle/>
+          <a:p>
+            <a:pPr algn="l">
+              <a:lnSpc>
+                <a:spcPct val="100000"/>
+              </a:lnSpc>
+            </a:pPr>
+            <a:r>
+              <a:rPr sz="1300" b="1" i="0">
+                <a:solidFill>
+                  <a:srgbClr val="1B2A44"/>
+                </a:solidFill>
+                <a:latin typeface="Calibri"/>
+              </a:rPr>
+              <a:t>Time-reversal (test time, no retraining)</a:t>
+            </a:r>
+          </a:p>
+        </p:txBody>
+      </p:sp>
+      <p:sp>
+        <p:nvSpPr>
+          <p:cNvPr id="22" name="TextBox 21"/>
+          <p:cNvSpPr txBox="1"/>
+          <p:nvPr/>
+        </p:nvSpPr>
+        <p:spPr>
+          <a:xfrm>
+            <a:off x="4069080" y="3867911"/>
+            <a:ext cx="2560320" cy="457200"/>
+          </a:xfrm>
+          <a:prstGeom prst="rect">
+            <a:avLst/>
+          </a:prstGeom>
+          <a:noFill/>
+        </p:spPr>
+        <p:txBody>
+          <a:bodyPr wrap="square" anchor="t" lIns="0" rIns="0" tIns="0" bIns="0">
+            <a:spAutoFit/>
+          </a:bodyPr>
+          <a:lstStyle/>
+          <a:p>
+            <a:pPr algn="l">
+              <a:lnSpc>
+                <a:spcPct val="100000"/>
+              </a:lnSpc>
+            </a:pPr>
+            <a:r>
+              <a:rPr sz="1250" b="0" i="0">
+                <a:solidFill>
+                  <a:srgbClr val="51607A"/>
+                </a:solidFill>
+                <a:latin typeface="Calibri"/>
+              </a:rPr>
+              <a:t>0.08 – 0.13</a:t>
+            </a:r>
+          </a:p>
+        </p:txBody>
+      </p:sp>
+      <p:sp>
+        <p:nvSpPr>
+          <p:cNvPr id="23" name="TextBox 22"/>
+          <p:cNvSpPr txBox="1"/>
+          <p:nvPr/>
+        </p:nvSpPr>
+        <p:spPr>
+          <a:xfrm>
+            <a:off x="6812280" y="3867911"/>
+            <a:ext cx="2560320" cy="457200"/>
+          </a:xfrm>
+          <a:prstGeom prst="rect">
+            <a:avLst/>
+          </a:prstGeom>
+          <a:noFill/>
+        </p:spPr>
+        <p:txBody>
+          <a:bodyPr wrap="square" anchor="t" lIns="0" rIns="0" tIns="0" bIns="0">
+            <a:spAutoFit/>
+          </a:bodyPr>
+          <a:lstStyle/>
+          <a:p>
+            <a:pPr algn="l">
+              <a:lnSpc>
+                <a:spcPct val="100000"/>
+              </a:lnSpc>
+            </a:pPr>
+            <a:r>
+              <a:rPr sz="1250" b="0" i="0">
+                <a:solidFill>
+                  <a:srgbClr val="51607A"/>
+                </a:solidFill>
+                <a:latin typeface="Calibri"/>
+              </a:rPr>
+              <a:t>Worst of all perturbations tested</a:t>
+            </a:r>
+          </a:p>
+        </p:txBody>
+      </p:sp>
+      <p:sp>
+        <p:nvSpPr>
+          <p:cNvPr id="24" name="TextBox 23"/>
+          <p:cNvSpPr txBox="1"/>
+          <p:nvPr/>
+        </p:nvSpPr>
+        <p:spPr>
+          <a:xfrm>
+            <a:off x="9555480" y="3822191"/>
+            <a:ext cx="1645920" cy="274320"/>
+          </a:xfrm>
+          <a:prstGeom prst="rect">
+            <a:avLst/>
+          </a:prstGeom>
+          <a:noFill/>
+        </p:spPr>
+        <p:txBody>
+          <a:bodyPr wrap="square" anchor="t" lIns="0" rIns="0" tIns="0" bIns="0">
+            <a:spAutoFit/>
+          </a:bodyPr>
+          <a:lstStyle/>
+          <a:p>
+            <a:pPr algn="l">
+              <a:lnSpc>
+                <a:spcPct val="100000"/>
+              </a:lnSpc>
+            </a:pPr>
+            <a:r>
+              <a:rPr sz="1300" b="1" i="0">
+                <a:solidFill>
+                  <a:srgbClr val="1F7A70"/>
+                </a:solidFill>
+                <a:latin typeface="Calibri"/>
+              </a:rPr>
+              <a:t>All 6</a:t>
+            </a:r>
+          </a:p>
+        </p:txBody>
+      </p:sp>
+      <p:sp>
+        <p:nvSpPr>
+          <p:cNvPr id="25" name="TextBox 24"/>
+          <p:cNvSpPr txBox="1"/>
+          <p:nvPr/>
+        </p:nvSpPr>
+        <p:spPr>
+          <a:xfrm>
+            <a:off x="9555480" y="4096511"/>
+            <a:ext cx="1645920" cy="274320"/>
+          </a:xfrm>
+          <a:prstGeom prst="rect">
+            <a:avLst/>
+          </a:prstGeom>
+          <a:noFill/>
+        </p:spPr>
+        <p:txBody>
+          <a:bodyPr wrap="square" anchor="t" lIns="0" rIns="0" tIns="0" bIns="0">
+            <a:spAutoFit/>
+          </a:bodyPr>
+          <a:lstStyle/>
+          <a:p>
+            <a:pPr algn="l">
+              <a:lnSpc>
+                <a:spcPct val="100000"/>
+              </a:lnSpc>
+            </a:pPr>
+            <a:r>
+              <a:rPr sz="1050" b="0" i="1">
+                <a:solidFill>
+                  <a:srgbClr val="51607A"/>
+                </a:solidFill>
+                <a:latin typeface="Calibri"/>
+              </a:rPr>
+              <a:t>configs</a:t>
+            </a:r>
+          </a:p>
+        </p:txBody>
+      </p:sp>
+      <p:sp>
+        <p:nvSpPr>
+          <p:cNvPr id="26" name="Rounded Rectangle 25"/>
+          <p:cNvSpPr/>
+          <p:nvPr/>
+        </p:nvSpPr>
+        <p:spPr>
+          <a:xfrm>
+            <a:off x="640080" y="4617720"/>
+            <a:ext cx="10881360" cy="1371600"/>
+          </a:xfrm>
+          <a:prstGeom prst="roundRect">
+            <a:avLst>
+              <a:gd name="adj" fmla="val 6000"/>
+            </a:avLst>
+          </a:prstGeom>
+          <a:solidFill>
+            <a:srgbClr val="E4EAF0"/>
+          </a:solidFill>
+          <a:ln>
+            <a:noFill/>
+          </a:ln>
+          <a:effectLst/>
+        </p:spPr>
+        <p:style>
+          <a:lnRef idx="1">
+            <a:schemeClr val="accent1"/>
+          </a:lnRef>
+          <a:fillRef idx="3">
+            <a:schemeClr val="accent1"/>
+          </a:fillRef>
+          <a:effectRef idx="2">
+            <a:schemeClr val="accent1"/>
+          </a:effectRef>
+          <a:fontRef idx="minor">
+            <a:schemeClr val="lt1"/>
+          </a:fontRef>
+        </p:style>
+        <p:txBody>
+          <a:bodyPr rtlCol="0" anchor="ctr" wrap="square" lIns="73152" rIns="73152" tIns="36576" bIns="36576"/>
+          <a:lstStyle/>
+          <a:p>
+            <a:pPr algn="l">
+              <a:lnSpc>
+                <a:spcPct val="130000"/>
+              </a:lnSpc>
+            </a:pPr>
+            <a:r>
+              <a:rPr sz="1350" b="0">
+                <a:solidFill>
+                  <a:srgbClr val="1B2A44"/>
+                </a:solidFill>
+                <a:latin typeface="Calibri"/>
+              </a:rPr>
+              <a:t>A flat MLP with zero learned temporal structure statistically ties GRU (p=0.73) once given the whole window — but the Transformer still beats that same flat MLP with 4× fewer parameters, real evidence attention finds structure recurrence and raw aggregation both miss. Reversing the sequence at test time causes near-total collapse across every trained model — temporal order clearly matters, just not in the way a simple GRU-vs-Transformer story implies.</a:t>
+            </a:r>
+          </a:p>
+        </p:txBody>
+      </p:sp>
+      <p:sp>
+        <p:nvSpPr>
+          <p:cNvPr id="27" name="TextBox 26"/>
+          <p:cNvSpPr txBox="1"/>
+          <p:nvPr/>
+        </p:nvSpPr>
+        <p:spPr>
+          <a:xfrm>
+            <a:off x="548640" y="6537960"/>
+            <a:ext cx="7315200" cy="274320"/>
+          </a:xfrm>
+          <a:prstGeom prst="rect">
+            <a:avLst/>
+          </a:prstGeom>
+          <a:noFill/>
+        </p:spPr>
+        <p:txBody>
+          <a:bodyPr wrap="square" anchor="t" lIns="0" rIns="0" tIns="0" bIns="0">
+            <a:spAutoFit/>
+          </a:bodyPr>
+          <a:lstStyle/>
+          <a:p>
+            <a:pPr algn="l">
+              <a:lnSpc>
+                <a:spcPct val="100000"/>
+              </a:lnSpc>
+            </a:pPr>
+            <a:r>
+              <a:rPr sz="900" b="0" i="0">
+                <a:solidFill>
+                  <a:srgbClr val="8C97A8"/>
+                </a:solidFill>
+                <a:latin typeface="Calibri"/>
+              </a:rPr>
+              <a:t>NeuroLens-RAG end-to-end report</a:t>
+            </a:r>
+          </a:p>
+        </p:txBody>
+      </p:sp>
+      <p:sp>
+        <p:nvSpPr>
+          <p:cNvPr id="28" name="TextBox 27"/>
+          <p:cNvSpPr txBox="1"/>
+          <p:nvPr/>
+        </p:nvSpPr>
+        <p:spPr>
+          <a:xfrm>
+            <a:off x="11247120" y="6537960"/>
+            <a:ext cx="457200" cy="274320"/>
+          </a:xfrm>
+          <a:prstGeom prst="rect">
+            <a:avLst/>
+          </a:prstGeom>
+          <a:noFill/>
+        </p:spPr>
+        <p:txBody>
+          <a:bodyPr wrap="square" anchor="t" lIns="0" rIns="0" tIns="0" bIns="0">
+            <a:spAutoFit/>
+          </a:bodyPr>
+          <a:lstStyle/>
+          <a:p>
+            <a:pPr algn="r">
+              <a:lnSpc>
+                <a:spcPct val="100000"/>
+              </a:lnSpc>
+            </a:pPr>
+            <a:r>
+              <a:rPr sz="900" b="0" i="0">
+                <a:solidFill>
+                  <a:srgbClr val="8C97A8"/>
+                </a:solidFill>
+                <a:latin typeface="Calibri"/>
+              </a:rPr>
+              <a:t>5b</a:t>
+            </a:r>
+          </a:p>
+        </p:txBody>
+      </p:sp>
+    </p:spTree>
+  </p:cSld>
+  <p:clrMapOvr>
+    <a:masterClrMapping/>
+  </p:clrMapOvr>
+</p:sld>
+</file>
+
+<file path=ppt/slides/slide14.xml><?xml version="1.0" encoding="utf-8"?>
+<p:sld xmlns:a="http://schemas.openxmlformats.org/drawingml/2006/main" xmlns:p="http://schemas.openxmlformats.org/presentationml/2006/main" xmlns:r="http://schemas.openxmlformats.org/officeDocument/2006/relationships">
+  <p:cSld>
+    <p:bg>
+      <p:bgPr>
+        <a:solidFill>
+          <a:srgbClr val="FFFFFF"/>
+        </a:solidFill>
+        <a:effectLst/>
+      </p:bgPr>
+    </p:bg>
+    <p:spTree>
+      <p:nvGrpSpPr>
+        <p:cNvPr id="1" name=""/>
+        <p:cNvGrpSpPr/>
+        <p:nvPr/>
+      </p:nvGrpSpPr>
+      <p:grpSpPr/>
+      <p:sp>
+        <p:nvSpPr>
+          <p:cNvPr id="2" name="TextBox 1"/>
+          <p:cNvSpPr txBox="1"/>
+          <p:nvPr/>
+        </p:nvSpPr>
+        <p:spPr>
+          <a:xfrm>
+            <a:off x="548640" y="292608"/>
+            <a:ext cx="7315200" cy="256032"/>
+          </a:xfrm>
+          <a:prstGeom prst="rect">
+            <a:avLst/>
+          </a:prstGeom>
+          <a:noFill/>
+        </p:spPr>
+        <p:txBody>
+          <a:bodyPr wrap="square" anchor="t" lIns="0" rIns="0" tIns="0" bIns="0">
+            <a:spAutoFit/>
+          </a:bodyPr>
+          <a:lstStyle/>
+          <a:p>
+            <a:pPr algn="l">
+              <a:lnSpc>
+                <a:spcPct val="100000"/>
+              </a:lnSpc>
+            </a:pPr>
+            <a:r>
+              <a:rPr sz="1100" b="1" i="0">
+                <a:solidFill>
+                  <a:srgbClr val="A5453A"/>
+                </a:solidFill>
+                <a:latin typeface="Calibri"/>
+              </a:rPr>
+              <a:t>DECOMPOSING TWO HEADLINE NUMBERS</a:t>
+            </a:r>
+          </a:p>
+        </p:txBody>
+      </p:sp>
+      <p:sp>
+        <p:nvSpPr>
+          <p:cNvPr id="3" name="TextBox 2"/>
+          <p:cNvSpPr txBox="1"/>
+          <p:nvPr/>
+        </p:nvSpPr>
+        <p:spPr>
+          <a:xfrm>
+            <a:off x="548640" y="603504"/>
+            <a:ext cx="11064240" cy="640080"/>
+          </a:xfrm>
+          <a:prstGeom prst="rect">
+            <a:avLst/>
+          </a:prstGeom>
+          <a:noFill/>
+        </p:spPr>
+        <p:txBody>
+          <a:bodyPr wrap="square" anchor="t" lIns="0" rIns="0" tIns="0" bIns="0">
+            <a:spAutoFit/>
+          </a:bodyPr>
+          <a:lstStyle/>
+          <a:p>
+            <a:pPr algn="l">
+              <a:lnSpc>
+                <a:spcPct val="100000"/>
+              </a:lnSpc>
+            </a:pPr>
+            <a:r>
+              <a:rPr sz="2800" b="1" i="0">
+                <a:solidFill>
+                  <a:srgbClr val="1B2A44"/>
+                </a:solidFill>
+                <a:latin typeface="Cambria"/>
+              </a:rPr>
+              <a:t>Retrieval ladder and a formal precision audit</a:t>
+            </a:r>
+          </a:p>
+        </p:txBody>
+      </p:sp>
+      <p:sp>
+        <p:nvSpPr>
+          <p:cNvPr id="4" name="Rounded Rectangle 3"/>
+          <p:cNvSpPr/>
+          <p:nvPr/>
+        </p:nvSpPr>
+        <p:spPr>
+          <a:xfrm>
+            <a:off x="640080" y="1600200"/>
+            <a:ext cx="5257800" cy="502920"/>
+          </a:xfrm>
+          <a:prstGeom prst="roundRect">
+            <a:avLst/>
+          </a:prstGeom>
+          <a:solidFill>
+            <a:srgbClr val="A5453A"/>
+          </a:solidFill>
+          <a:ln>
+            <a:noFill/>
+          </a:ln>
+          <a:effectLst/>
+        </p:spPr>
+        <p:style>
+          <a:lnRef idx="1">
+            <a:schemeClr val="accent1"/>
+          </a:lnRef>
+          <a:fillRef idx="3">
+            <a:schemeClr val="accent1"/>
+          </a:fillRef>
+          <a:effectRef idx="2">
+            <a:schemeClr val="accent1"/>
+          </a:effectRef>
+          <a:fontRef idx="minor">
+            <a:schemeClr val="lt1"/>
+          </a:fontRef>
+        </p:style>
+        <p:txBody>
+          <a:bodyPr rtlCol="0" anchor="ctr" wrap="square" lIns="73152" rIns="73152" tIns="36576" bIns="36576"/>
+          <a:lstStyle/>
+          <a:p>
+            <a:pPr algn="ctr">
+              <a:lnSpc>
+                <a:spcPct val="100000"/>
+              </a:lnSpc>
+            </a:pPr>
+            <a:r>
+              <a:rPr sz="1350" b="1">
+                <a:solidFill>
+                  <a:srgbClr val="FFFFFF"/>
+                </a:solidFill>
+                <a:latin typeface="Calibri"/>
+              </a:rPr>
+              <a:t>Retrieval ablation ladder</a:t>
+            </a:r>
+          </a:p>
+        </p:txBody>
+      </p:sp>
+      <p:sp>
+        <p:nvSpPr>
+          <p:cNvPr id="5" name="Rounded Rectangle 4"/>
+          <p:cNvSpPr/>
+          <p:nvPr/>
+        </p:nvSpPr>
+        <p:spPr>
+          <a:xfrm>
+            <a:off x="640080" y="2194560"/>
+            <a:ext cx="5257800" cy="1417320"/>
+          </a:xfrm>
+          <a:prstGeom prst="roundRect">
+            <a:avLst/>
+          </a:prstGeom>
+          <a:solidFill>
+            <a:srgbClr val="ECEDEF"/>
+          </a:solidFill>
+          <a:ln>
+            <a:noFill/>
+          </a:ln>
+          <a:effectLst/>
+        </p:spPr>
+        <p:style>
+          <a:lnRef idx="1">
+            <a:schemeClr val="accent1"/>
+          </a:lnRef>
+          <a:fillRef idx="3">
+            <a:schemeClr val="accent1"/>
+          </a:fillRef>
+          <a:effectRef idx="2">
+            <a:schemeClr val="accent1"/>
+          </a:effectRef>
+          <a:fontRef idx="minor">
+            <a:schemeClr val="lt1"/>
+          </a:fontRef>
+        </p:style>
+        <p:txBody>
+          <a:bodyPr rtlCol="0" anchor="ctr" wrap="square" lIns="73152" rIns="73152" tIns="36576" bIns="36576"/>
+          <a:lstStyle/>
+          <a:p>
+            <a:pPr algn="l">
+              <a:lnSpc>
+                <a:spcPct val="120000"/>
+              </a:lnSpc>
+            </a:pPr>
+            <a:r>
+              <a:rPr sz="1200" b="1">
+                <a:solidFill>
+                  <a:srgbClr val="1B2A44"/>
+                </a:solidFill>
+                <a:latin typeface="Calibri"/>
+              </a:rPr>
+              <a:t>COMPONENTS</a:t>
+            </a:r>
+          </a:p>
+          <a:p>
+            <a:pPr algn="l">
+              <a:lnSpc>
+                <a:spcPct val="120000"/>
+              </a:lnSpc>
+            </a:pPr>
+            <a:r>
+              <a:rPr sz="1200" b="0">
+                <a:solidFill>
+                  <a:srgbClr val="1B2A44"/>
+                </a:solidFill>
+                <a:latin typeface="Calibri"/>
+              </a:rPr>
+              <a:t>BM25 0.460 recall@1 • frozen MiniLM 0.460 (a tie!) • adapted MiniLM 0.500 • frozen+reranker 0.740 • adapted+reranker 0.740 • oracle 1.000</a:t>
+            </a:r>
+          </a:p>
+        </p:txBody>
+      </p:sp>
+      <p:cxnSp>
+        <p:nvCxnSpPr>
+          <p:cNvPr id="6" name="Connector 5"/>
+          <p:cNvCxnSpPr/>
+          <p:nvPr/>
+        </p:nvCxnSpPr>
+        <p:spPr>
+          <a:xfrm>
+            <a:off x="3268980" y="3703320"/>
+            <a:ext cx="0" cy="228600"/>
+          </a:xfrm>
+          <a:prstGeom prst="line">
+            <a:avLst/>
+          </a:prstGeom>
+          <a:ln w="25400">
+            <a:solidFill>
+              <a:srgbClr val="A5453A"/>
+            </a:solidFill>
+            <a:tailEnd type="triangle" w="med" len="med"/>
+          </a:ln>
+        </p:spPr>
+        <p:style>
+          <a:lnRef idx="2">
+            <a:schemeClr val="accent1"/>
+          </a:lnRef>
+          <a:fillRef idx="0">
+            <a:schemeClr val="accent1"/>
+          </a:fillRef>
+          <a:effectRef idx="1">
+            <a:schemeClr val="accent1"/>
+          </a:effectRef>
+          <a:fontRef idx="minor">
+            <a:schemeClr val="tx1"/>
+          </a:fontRef>
+        </p:style>
+      </p:cxnSp>
+      <p:sp>
+        <p:nvSpPr>
+          <p:cNvPr id="7" name="Rounded Rectangle 6"/>
+          <p:cNvSpPr/>
+          <p:nvPr/>
+        </p:nvSpPr>
+        <p:spPr>
+          <a:xfrm>
+            <a:off x="640080" y="4023360"/>
+            <a:ext cx="5257800" cy="1691640"/>
+          </a:xfrm>
+          <a:prstGeom prst="roundRect">
+            <a:avLst/>
+          </a:prstGeom>
+          <a:solidFill>
+            <a:srgbClr val="F3E1DE"/>
+          </a:solidFill>
+          <a:ln>
+            <a:noFill/>
+          </a:ln>
+          <a:effectLst/>
+        </p:spPr>
+        <p:style>
+          <a:lnRef idx="1">
+            <a:schemeClr val="accent1"/>
+          </a:lnRef>
+          <a:fillRef idx="3">
+            <a:schemeClr val="accent1"/>
+          </a:fillRef>
+          <a:effectRef idx="2">
+            <a:schemeClr val="accent1"/>
+          </a:effectRef>
+          <a:fontRef idx="minor">
+            <a:schemeClr val="lt1"/>
+          </a:fontRef>
+        </p:style>
+        <p:txBody>
+          <a:bodyPr rtlCol="0" anchor="ctr" wrap="square" lIns="73152" rIns="73152" tIns="36576" bIns="36576"/>
+          <a:lstStyle/>
+          <a:p>
+            <a:pPr algn="l">
+              <a:lnSpc>
+                <a:spcPct val="120000"/>
+              </a:lnSpc>
+            </a:pPr>
+            <a:r>
+              <a:rPr sz="1250" b="1">
+                <a:solidFill>
+                  <a:srgbClr val="1B2A44"/>
+                </a:solidFill>
+                <a:latin typeface="Calibri"/>
+              </a:rPr>
+              <a:t>THE STORY</a:t>
+            </a:r>
+          </a:p>
+          <a:p>
+            <a:pPr algn="l">
+              <a:lnSpc>
+                <a:spcPct val="120000"/>
+              </a:lnSpc>
+            </a:pPr>
+            <a:r>
+              <a:rPr sz="1250" b="0">
+                <a:solidFill>
+                  <a:srgbClr val="1B2A44"/>
+                </a:solidFill>
+                <a:latin typeface="Calibri"/>
+              </a:rPr>
+              <a:t>Reranking, not fine-tuning, does most of the work</a:t>
+            </a:r>
+          </a:p>
+          <a:p>
+            <a:pPr algn="l">
+              <a:lnSpc>
+                <a:spcPct val="120000"/>
+              </a:lnSpc>
+            </a:pPr>
+            <a:r>
+              <a:rPr sz="1250" b="0">
+                <a:solidFill>
+                  <a:srgbClr val="1B2A44"/>
+                </a:solidFill>
+                <a:latin typeface="Calibri"/>
+              </a:rPr>
+              <a:t/>
+            </a:r>
+          </a:p>
+          <a:p>
+            <a:pPr algn="l">
+              <a:lnSpc>
+                <a:spcPct val="120000"/>
+              </a:lnSpc>
+            </a:pPr>
+            <a:r>
+              <a:rPr sz="1250" b="0">
+                <a:solidFill>
+                  <a:srgbClr val="1B2A44"/>
+                </a:solidFill>
+                <a:latin typeface="Calibri"/>
+              </a:rPr>
+              <a:t>Frozen MiniLM + reranker (0.740) already matches adapted + reranker — once reranking is in the loop, embedding fine-tuning barely moves the needle.</a:t>
+            </a:r>
+          </a:p>
+        </p:txBody>
+      </p:sp>
+      <p:sp>
+        <p:nvSpPr>
+          <p:cNvPr id="8" name="Rounded Rectangle 7"/>
+          <p:cNvSpPr/>
+          <p:nvPr/>
+        </p:nvSpPr>
+        <p:spPr>
+          <a:xfrm>
+            <a:off x="6309360" y="1600200"/>
+            <a:ext cx="5257800" cy="502920"/>
+          </a:xfrm>
+          <a:prstGeom prst="roundRect">
+            <a:avLst/>
+          </a:prstGeom>
+          <a:solidFill>
+            <a:srgbClr val="1B2A44"/>
+          </a:solidFill>
+          <a:ln>
+            <a:noFill/>
+          </a:ln>
+          <a:effectLst/>
+        </p:spPr>
+        <p:style>
+          <a:lnRef idx="1">
+            <a:schemeClr val="accent1"/>
+          </a:lnRef>
+          <a:fillRef idx="3">
+            <a:schemeClr val="accent1"/>
+          </a:fillRef>
+          <a:effectRef idx="2">
+            <a:schemeClr val="accent1"/>
+          </a:effectRef>
+          <a:fontRef idx="minor">
+            <a:schemeClr val="lt1"/>
+          </a:fontRef>
+        </p:style>
+        <p:txBody>
+          <a:bodyPr rtlCol="0" anchor="ctr" wrap="square" lIns="73152" rIns="73152" tIns="36576" bIns="36576"/>
+          <a:lstStyle/>
+          <a:p>
+            <a:pPr algn="ctr">
+              <a:lnSpc>
+                <a:spcPct val="100000"/>
+              </a:lnSpc>
+            </a:pPr>
+            <a:r>
+              <a:rPr sz="1350" b="1">
+                <a:solidFill>
+                  <a:srgbClr val="FFFFFF"/>
+                </a:solidFill>
+                <a:latin typeface="Calibri"/>
+              </a:rPr>
+              <a:t>Verification-stance precision audit (18-example self-labeled gold set)</a:t>
+            </a:r>
+          </a:p>
+        </p:txBody>
+      </p:sp>
+      <p:sp>
+        <p:nvSpPr>
+          <p:cNvPr id="9" name="Rounded Rectangle 8"/>
+          <p:cNvSpPr/>
+          <p:nvPr/>
+        </p:nvSpPr>
+        <p:spPr>
+          <a:xfrm>
+            <a:off x="6309360" y="2194560"/>
+            <a:ext cx="5257800" cy="1417320"/>
+          </a:xfrm>
+          <a:prstGeom prst="roundRect">
+            <a:avLst/>
+          </a:prstGeom>
+          <a:solidFill>
+            <a:srgbClr val="ECEDEF"/>
+          </a:solidFill>
+          <a:ln>
+            <a:noFill/>
+          </a:ln>
+          <a:effectLst/>
+        </p:spPr>
+        <p:style>
+          <a:lnRef idx="1">
+            <a:schemeClr val="accent1"/>
+          </a:lnRef>
+          <a:fillRef idx="3">
+            <a:schemeClr val="accent1"/>
+          </a:fillRef>
+          <a:effectRef idx="2">
+            <a:schemeClr val="accent1"/>
+          </a:effectRef>
+          <a:fontRef idx="minor">
+            <a:schemeClr val="lt1"/>
+          </a:fontRef>
+        </p:style>
+        <p:txBody>
+          <a:bodyPr rtlCol="0" anchor="ctr" wrap="square" lIns="73152" rIns="73152" tIns="36576" bIns="36576"/>
+          <a:lstStyle/>
+          <a:p>
+            <a:pPr algn="l">
+              <a:lnSpc>
+                <a:spcPct val="120000"/>
+              </a:lnSpc>
+            </a:pPr>
+            <a:r>
+              <a:rPr sz="1200" b="1">
+                <a:solidFill>
+                  <a:srgbClr val="1B2A44"/>
+                </a:solidFill>
+                <a:latin typeface="Calibri"/>
+              </a:rPr>
+              <a:t>GROUNDING ALONE</a:t>
+            </a:r>
+          </a:p>
+          <a:p>
+            <a:pPr algn="l">
+              <a:lnSpc>
+                <a:spcPct val="120000"/>
+              </a:lnSpc>
+            </a:pPr>
+            <a:r>
+              <a:rPr sz="1200" b="0">
+                <a:solidFill>
+                  <a:srgbClr val="1B2A44"/>
+                </a:solidFill>
+                <a:latin typeface="Calibri"/>
+              </a:rPr>
+              <a:t>Accuracy 0.500, identical to free judgment — quote-grounding alone caught 0 of 4 related-but-insufficient cases.</a:t>
+            </a:r>
+          </a:p>
+        </p:txBody>
+      </p:sp>
+      <p:cxnSp>
+        <p:nvCxnSpPr>
+          <p:cNvPr id="10" name="Connector 9"/>
+          <p:cNvCxnSpPr/>
+          <p:nvPr/>
+        </p:nvCxnSpPr>
+        <p:spPr>
+          <a:xfrm>
+            <a:off x="8938260" y="3703320"/>
+            <a:ext cx="0" cy="228600"/>
+          </a:xfrm>
+          <a:prstGeom prst="line">
+            <a:avLst/>
+          </a:prstGeom>
+          <a:ln w="25400">
+            <a:solidFill>
+              <a:srgbClr val="1B2A44"/>
+            </a:solidFill>
+            <a:tailEnd type="triangle" w="med" len="med"/>
+          </a:ln>
+        </p:spPr>
+        <p:style>
+          <a:lnRef idx="2">
+            <a:schemeClr val="accent1"/>
+          </a:lnRef>
+          <a:fillRef idx="0">
+            <a:schemeClr val="accent1"/>
+          </a:fillRef>
+          <a:effectRef idx="1">
+            <a:schemeClr val="accent1"/>
+          </a:effectRef>
+          <a:fontRef idx="minor">
+            <a:schemeClr val="tx1"/>
+          </a:fontRef>
+        </p:style>
+      </p:cxnSp>
+      <p:sp>
+        <p:nvSpPr>
+          <p:cNvPr id="11" name="Rounded Rectangle 10"/>
+          <p:cNvSpPr/>
+          <p:nvPr/>
+        </p:nvSpPr>
+        <p:spPr>
+          <a:xfrm>
+            <a:off x="6309360" y="4023360"/>
+            <a:ext cx="5257800" cy="1691640"/>
+          </a:xfrm>
+          <a:prstGeom prst="roundRect">
+            <a:avLst/>
+          </a:prstGeom>
+          <a:solidFill>
+            <a:srgbClr val="E4EAF0"/>
+          </a:solidFill>
+          <a:ln>
+            <a:noFill/>
+          </a:ln>
+          <a:effectLst/>
+        </p:spPr>
+        <p:style>
+          <a:lnRef idx="1">
+            <a:schemeClr val="accent1"/>
+          </a:lnRef>
+          <a:fillRef idx="3">
+            <a:schemeClr val="accent1"/>
+          </a:fillRef>
+          <a:effectRef idx="2">
+            <a:schemeClr val="accent1"/>
+          </a:effectRef>
+          <a:fontRef idx="minor">
+            <a:schemeClr val="lt1"/>
+          </a:fontRef>
+        </p:style>
+        <p:txBody>
+          <a:bodyPr rtlCol="0" anchor="ctr" wrap="square" lIns="73152" rIns="73152" tIns="36576" bIns="36576"/>
+          <a:lstStyle/>
+          <a:p>
+            <a:pPr algn="l">
+              <a:lnSpc>
+                <a:spcPct val="120000"/>
+              </a:lnSpc>
+            </a:pPr>
+            <a:r>
+              <a:rPr sz="1250" b="1">
+                <a:solidFill>
+                  <a:srgbClr val="1B2A44"/>
+                </a:solidFill>
+                <a:latin typeface="Calibri"/>
+              </a:rPr>
+              <a:t>+ AXIS CHECK</a:t>
+            </a:r>
+          </a:p>
+          <a:p>
+            <a:pPr algn="l">
+              <a:lnSpc>
+                <a:spcPct val="120000"/>
+              </a:lnSpc>
+            </a:pPr>
+            <a:r>
+              <a:rPr sz="1250" b="0">
+                <a:solidFill>
+                  <a:srgbClr val="1B2A44"/>
+                </a:solidFill>
+                <a:latin typeface="Calibri"/>
+              </a:rPr>
+              <a:t>Accuracy 0.667, catches 4 of 4 — but CONTRADICTS recall drops 0.40→0.20</a:t>
+            </a:r>
+          </a:p>
+          <a:p>
+            <a:pPr algn="l">
+              <a:lnSpc>
+                <a:spcPct val="120000"/>
+              </a:lnSpc>
+            </a:pPr>
+            <a:r>
+              <a:rPr sz="1250" b="0">
+                <a:solidFill>
+                  <a:srgbClr val="1B2A44"/>
+                </a:solidFill>
+                <a:latin typeface="Calibri"/>
+              </a:rPr>
+              <a:t/>
+            </a:r>
+          </a:p>
+          <a:p>
+            <a:pPr algn="l">
+              <a:lnSpc>
+                <a:spcPct val="120000"/>
+              </a:lnSpc>
+            </a:pPr>
+            <a:r>
+              <a:rPr sz="1250" b="0">
+                <a:solidFill>
+                  <a:srgbClr val="1B2A44"/>
+                </a:solidFill>
+                <a:latin typeface="Calibri"/>
+              </a:rPr>
+              <a:t>A real tradeoff, not a free win: the axis-check trades sensitivity for specificity. Self-labeled, not independently blind-annotated.</a:t>
+            </a:r>
+          </a:p>
+        </p:txBody>
+      </p:sp>
+      <p:sp>
+        <p:nvSpPr>
+          <p:cNvPr id="12" name="TextBox 11"/>
+          <p:cNvSpPr txBox="1"/>
+          <p:nvPr/>
+        </p:nvSpPr>
+        <p:spPr>
+          <a:xfrm>
+            <a:off x="548640" y="6537960"/>
+            <a:ext cx="7315200" cy="274320"/>
+          </a:xfrm>
+          <a:prstGeom prst="rect">
+            <a:avLst/>
+          </a:prstGeom>
+          <a:noFill/>
+        </p:spPr>
+        <p:txBody>
+          <a:bodyPr wrap="square" anchor="t" lIns="0" rIns="0" tIns="0" bIns="0">
+            <a:spAutoFit/>
+          </a:bodyPr>
+          <a:lstStyle/>
+          <a:p>
+            <a:pPr algn="l">
+              <a:lnSpc>
+                <a:spcPct val="100000"/>
+              </a:lnSpc>
+            </a:pPr>
+            <a:r>
+              <a:rPr sz="900" b="0" i="0">
+                <a:solidFill>
+                  <a:srgbClr val="8C97A8"/>
+                </a:solidFill>
+                <a:latin typeface="Calibri"/>
+              </a:rPr>
+              <a:t>NeuroLens-RAG end-to-end report</a:t>
+            </a:r>
+          </a:p>
+        </p:txBody>
+      </p:sp>
+      <p:sp>
+        <p:nvSpPr>
+          <p:cNvPr id="13" name="TextBox 12"/>
+          <p:cNvSpPr txBox="1"/>
+          <p:nvPr/>
+        </p:nvSpPr>
+        <p:spPr>
+          <a:xfrm>
+            <a:off x="11247120" y="6537960"/>
+            <a:ext cx="457200" cy="274320"/>
+          </a:xfrm>
+          <a:prstGeom prst="rect">
+            <a:avLst/>
+          </a:prstGeom>
+          <a:noFill/>
+        </p:spPr>
+        <p:txBody>
+          <a:bodyPr wrap="square" anchor="t" lIns="0" rIns="0" tIns="0" bIns="0">
+            <a:spAutoFit/>
+          </a:bodyPr>
+          <a:lstStyle/>
+          <a:p>
+            <a:pPr algn="r">
+              <a:lnSpc>
+                <a:spcPct val="100000"/>
+              </a:lnSpc>
+            </a:pPr>
+            <a:r>
+              <a:rPr sz="900" b="0" i="0">
+                <a:solidFill>
+                  <a:srgbClr val="8C97A8"/>
+                </a:solidFill>
+                <a:latin typeface="Calibri"/>
+              </a:rPr>
+              <a:t>10b</a:t>
             </a:r>
           </a:p>
         </p:txBody>
@@ -11786,7 +13665,7 @@
                 </a:solidFill>
                 <a:latin typeface="Calibri"/>
               </a:rPr>
-              <a:t>(8 papers)</a:t>
+              <a:t>(10 papers)</a:t>
             </a:r>
           </a:p>
         </p:txBody>

</xml_diff>